<commit_message>
modify lab pptx for working code
</commit_message>
<xml_diff>
--- a/3일차_실습1_latest.pptx
+++ b/3일차_실습1_latest.pptx
@@ -16995,7 +16995,7 @@
         <p:spPr>
           <a:xfrm>
             <a:off x="6035040" y="594359"/>
-            <a:ext cx="5852160" cy="6263641"/>
+            <a:ext cx="5852160" cy="5001371"/>
           </a:xfrm>
           <a:prstGeom prst="rect">
             <a:avLst/>
@@ -17780,7 +17780,7 @@
         </p:nvSpPr>
         <p:spPr>
           <a:xfrm>
-            <a:off x="6172200" y="6603756"/>
+            <a:off x="6172200" y="5271914"/>
             <a:ext cx="5577840" cy="228600"/>
           </a:xfrm>
           <a:prstGeom prst="rect">
@@ -18060,38 +18060,10 @@
                 <a:ea typeface="Consolas" pitchFamily="34" charset="-122"/>
                 <a:cs typeface="Consolas" pitchFamily="34" charset="-120"/>
               </a:rPr>
-              <a:t>import os, google.genai as genai</a:t>
-            </a:r>
-            <a:endParaRPr lang="en-US" sz="950" dirty="0"/>
-          </a:p>
-        </p:txBody>
-      </p:sp>
-      <p:sp>
-        <p:nvSpPr>
-          <p:cNvPr id="28" name="Text 26"/>
-          <p:cNvSpPr/>
-          <p:nvPr/>
-        </p:nvSpPr>
-        <p:spPr>
-          <a:xfrm>
-            <a:off x="6172200" y="1938528"/>
-            <a:ext cx="5577840" cy="228600"/>
-          </a:xfrm>
-          <a:prstGeom prst="rect">
-            <a:avLst/>
-          </a:prstGeom>
-          <a:noFill/>
-          <a:ln/>
-        </p:spPr>
-        <p:txBody>
-          <a:bodyPr wrap="square" lIns="0" tIns="0" rIns="0" bIns="0" rtlCol="0" anchor="ctr"/>
-          <a:lstStyle/>
-          <a:p>
-            <a:pPr marL="0" indent="0">
-              <a:buNone/>
-            </a:pPr>
-            <a:r>
-              <a:rPr lang="en-US" sz="950" dirty="0">
+              <a:t>import </a:t>
+            </a:r>
+            <a:r>
+              <a:rPr lang="en-US" sz="950" dirty="0" err="1">
                 <a:solidFill>
                   <a:srgbClr val="E6EDF3"/>
                 </a:solidFill>
@@ -18099,36 +18071,8 @@
                 <a:ea typeface="Consolas" pitchFamily="34" charset="-122"/>
                 <a:cs typeface="Consolas" pitchFamily="34" charset="-120"/>
               </a:rPr>
-              <a:t>try:</a:t>
-            </a:r>
-            <a:endParaRPr lang="en-US" sz="950" dirty="0"/>
-          </a:p>
-        </p:txBody>
-      </p:sp>
-      <p:sp>
-        <p:nvSpPr>
-          <p:cNvPr id="29" name="Text 27"/>
-          <p:cNvSpPr/>
-          <p:nvPr/>
-        </p:nvSpPr>
-        <p:spPr>
-          <a:xfrm>
-            <a:off x="6172200" y="2185416"/>
-            <a:ext cx="5577840" cy="228600"/>
-          </a:xfrm>
-          <a:prstGeom prst="rect">
-            <a:avLst/>
-          </a:prstGeom>
-          <a:noFill/>
-          <a:ln/>
-        </p:spPr>
-        <p:txBody>
-          <a:bodyPr wrap="square" lIns="0" tIns="0" rIns="0" bIns="0" rtlCol="0" anchor="ctr"/>
-          <a:lstStyle/>
-          <a:p>
-            <a:pPr marL="0" indent="0">
-              <a:buNone/>
-            </a:pPr>
+              <a:t>os</a:t>
+            </a:r>
             <a:r>
               <a:rPr lang="en-US" sz="950" dirty="0">
                 <a:solidFill>
@@ -18138,38 +18082,10 @@
                 <a:ea typeface="Consolas" pitchFamily="34" charset="-122"/>
                 <a:cs typeface="Consolas" pitchFamily="34" charset="-120"/>
               </a:rPr>
-              <a:t>  from google.colab import userdata</a:t>
-            </a:r>
-            <a:endParaRPr lang="en-US" sz="950" dirty="0"/>
-          </a:p>
-        </p:txBody>
-      </p:sp>
-      <p:sp>
-        <p:nvSpPr>
-          <p:cNvPr id="30" name="Text 28"/>
-          <p:cNvSpPr/>
-          <p:nvPr/>
-        </p:nvSpPr>
-        <p:spPr>
-          <a:xfrm>
-            <a:off x="6172200" y="2432304"/>
-            <a:ext cx="5577840" cy="228600"/>
-          </a:xfrm>
-          <a:prstGeom prst="rect">
-            <a:avLst/>
-          </a:prstGeom>
-          <a:noFill/>
-          <a:ln/>
-        </p:spPr>
-        <p:txBody>
-          <a:bodyPr wrap="square" lIns="0" tIns="0" rIns="0" bIns="0" rtlCol="0" anchor="ctr"/>
-          <a:lstStyle/>
-          <a:p>
-            <a:pPr marL="0" indent="0">
-              <a:buNone/>
-            </a:pPr>
-            <a:r>
-              <a:rPr lang="en-US" sz="950" dirty="0">
+              <a:t>, google-</a:t>
+            </a:r>
+            <a:r>
+              <a:rPr lang="en-US" sz="950" dirty="0" err="1">
                 <a:solidFill>
                   <a:srgbClr val="E6EDF3"/>
                 </a:solidFill>
@@ -18177,36 +18093,8 @@
                 <a:ea typeface="Consolas" pitchFamily="34" charset="-122"/>
                 <a:cs typeface="Consolas" pitchFamily="34" charset="-120"/>
               </a:rPr>
-              <a:t>  GEMINI_API_KEY=userdata.get('GEMINI_API_KEY')</a:t>
-            </a:r>
-            <a:endParaRPr lang="en-US" sz="950" dirty="0"/>
-          </a:p>
-        </p:txBody>
-      </p:sp>
-      <p:sp>
-        <p:nvSpPr>
-          <p:cNvPr id="31" name="Text 29"/>
-          <p:cNvSpPr/>
-          <p:nvPr/>
-        </p:nvSpPr>
-        <p:spPr>
-          <a:xfrm>
-            <a:off x="6172200" y="2679192"/>
-            <a:ext cx="5577840" cy="228600"/>
-          </a:xfrm>
-          <a:prstGeom prst="rect">
-            <a:avLst/>
-          </a:prstGeom>
-          <a:noFill/>
-          <a:ln/>
-        </p:spPr>
-        <p:txBody>
-          <a:bodyPr wrap="square" lIns="0" tIns="0" rIns="0" bIns="0" rtlCol="0" anchor="ctr"/>
-          <a:lstStyle/>
-          <a:p>
-            <a:pPr marL="0" indent="0">
-              <a:buNone/>
-            </a:pPr>
+              <a:t>genai</a:t>
+            </a:r>
             <a:r>
               <a:rPr lang="en-US" sz="950" dirty="0">
                 <a:solidFill>
@@ -18216,38 +18104,10 @@
                 <a:ea typeface="Consolas" pitchFamily="34" charset="-122"/>
                 <a:cs typeface="Consolas" pitchFamily="34" charset="-120"/>
               </a:rPr>
-              <a:t>except ImportError:</a:t>
-            </a:r>
-            <a:endParaRPr lang="en-US" sz="950" dirty="0"/>
-          </a:p>
-        </p:txBody>
-      </p:sp>
-      <p:sp>
-        <p:nvSpPr>
-          <p:cNvPr id="32" name="Text 30"/>
-          <p:cNvSpPr/>
-          <p:nvPr/>
-        </p:nvSpPr>
-        <p:spPr>
-          <a:xfrm>
-            <a:off x="6172200" y="2926080"/>
-            <a:ext cx="5577840" cy="228600"/>
-          </a:xfrm>
-          <a:prstGeom prst="rect">
-            <a:avLst/>
-          </a:prstGeom>
-          <a:noFill/>
-          <a:ln/>
-        </p:spPr>
-        <p:txBody>
-          <a:bodyPr wrap="square" lIns="0" tIns="0" rIns="0" bIns="0" rtlCol="0" anchor="ctr"/>
-          <a:lstStyle/>
-          <a:p>
-            <a:pPr marL="0" indent="0">
-              <a:buNone/>
-            </a:pPr>
-            <a:r>
-              <a:rPr lang="en-US" sz="950" dirty="0">
+              <a:t> as </a:t>
+            </a:r>
+            <a:r>
+              <a:rPr lang="en-US" sz="950" dirty="0" err="1">
                 <a:solidFill>
                   <a:srgbClr val="E6EDF3"/>
                 </a:solidFill>
@@ -18255,7 +18115,7 @@
                 <a:ea typeface="Consolas" pitchFamily="34" charset="-122"/>
                 <a:cs typeface="Consolas" pitchFamily="34" charset="-120"/>
               </a:rPr>
-              <a:t>  from dotenv import load_dotenv</a:t>
+              <a:t>genai</a:t>
             </a:r>
             <a:endParaRPr lang="en-US" sz="950" dirty="0"/>
           </a:p>
@@ -18263,13 +18123,13 @@
       </p:sp>
       <p:sp>
         <p:nvSpPr>
-          <p:cNvPr id="33" name="Text 31"/>
-          <p:cNvSpPr/>
-          <p:nvPr/>
-        </p:nvSpPr>
-        <p:spPr>
-          <a:xfrm>
-            <a:off x="6172200" y="3172968"/>
+          <p:cNvPr id="29" name="Text 27"/>
+          <p:cNvSpPr/>
+          <p:nvPr/>
+        </p:nvSpPr>
+        <p:spPr>
+          <a:xfrm>
+            <a:off x="6042991" y="1926999"/>
             <a:ext cx="5577840" cy="228600"/>
           </a:xfrm>
           <a:prstGeom prst="rect">
@@ -18294,7 +18154,7 @@
                 <a:ea typeface="Consolas" pitchFamily="34" charset="-122"/>
                 <a:cs typeface="Consolas" pitchFamily="34" charset="-120"/>
               </a:rPr>
-              <a:t>  load_dotenv('.env', override=True)</a:t>
+              <a:t>  from google.colab import userdata</a:t>
             </a:r>
             <a:endParaRPr lang="en-US" sz="950" dirty="0"/>
           </a:p>
@@ -18302,13 +18162,13 @@
       </p:sp>
       <p:sp>
         <p:nvSpPr>
-          <p:cNvPr id="34" name="Text 32"/>
-          <p:cNvSpPr/>
-          <p:nvPr/>
-        </p:nvSpPr>
-        <p:spPr>
-          <a:xfrm>
-            <a:off x="6172200" y="3419856"/>
+          <p:cNvPr id="30" name="Text 28"/>
+          <p:cNvSpPr/>
+          <p:nvPr/>
+        </p:nvSpPr>
+        <p:spPr>
+          <a:xfrm>
+            <a:off x="6062870" y="2422365"/>
             <a:ext cx="5577840" cy="228600"/>
           </a:xfrm>
           <a:prstGeom prst="rect">
@@ -18333,7 +18193,7 @@
                 <a:ea typeface="Consolas" pitchFamily="34" charset="-122"/>
                 <a:cs typeface="Consolas" pitchFamily="34" charset="-120"/>
               </a:rPr>
-              <a:t>  GEMINI_API_KEY=os.environ.get('GEMINI_API_KEY')</a:t>
+              <a:t>  GEMINI_API_KEY=userdata.get('GEMINI_API_KEY')</a:t>
             </a:r>
             <a:endParaRPr lang="en-US" sz="950" dirty="0"/>
           </a:p>
@@ -18341,13 +18201,13 @@
       </p:sp>
       <p:sp>
         <p:nvSpPr>
-          <p:cNvPr id="35" name="Text 33"/>
-          <p:cNvSpPr/>
-          <p:nvPr/>
-        </p:nvSpPr>
-        <p:spPr>
-          <a:xfrm>
-            <a:off x="6172200" y="3666744"/>
+          <p:cNvPr id="36" name="Text 34"/>
+          <p:cNvSpPr/>
+          <p:nvPr/>
+        </p:nvSpPr>
+        <p:spPr>
+          <a:xfrm>
+            <a:off x="6172200" y="3913632"/>
             <a:ext cx="5577840" cy="228600"/>
           </a:xfrm>
           <a:prstGeom prst="rect">
@@ -18363,16 +18223,44 @@
             <a:pPr marL="0" indent="0">
               <a:buNone/>
             </a:pPr>
+            <a:endParaRPr lang="en-US" sz="950" dirty="0"/>
+          </a:p>
+        </p:txBody>
+      </p:sp>
+      <p:sp>
+        <p:nvSpPr>
+          <p:cNvPr id="37" name="Text 35"/>
+          <p:cNvSpPr/>
+          <p:nvPr/>
+        </p:nvSpPr>
+        <p:spPr>
+          <a:xfrm>
+            <a:off x="6192079" y="2878373"/>
+            <a:ext cx="5577840" cy="228600"/>
+          </a:xfrm>
+          <a:prstGeom prst="rect">
+            <a:avLst/>
+          </a:prstGeom>
+          <a:noFill/>
+          <a:ln/>
+        </p:spPr>
+        <p:txBody>
+          <a:bodyPr wrap="square" lIns="0" tIns="0" rIns="0" bIns="0" rtlCol="0" anchor="ctr"/>
+          <a:lstStyle/>
+          <a:p>
+            <a:pPr marL="0" indent="0">
+              <a:buNone/>
+            </a:pPr>
             <a:r>
               <a:rPr lang="en-US" sz="950" dirty="0">
                 <a:solidFill>
-                  <a:srgbClr val="E6EDF3"/>
+                  <a:srgbClr val="F59E0B"/>
                 </a:solidFill>
                 <a:latin typeface="Consolas" pitchFamily="34" charset="0"/>
                 <a:ea typeface="Consolas" pitchFamily="34" charset="-122"/>
                 <a:cs typeface="Consolas" pitchFamily="34" charset="-120"/>
               </a:rPr>
-              <a:t>genai.configure(api_key=GEMINI_API_KEY)</a:t>
+              <a:t>MODEL = 'gemini-2.5-flash-lite'</a:t>
             </a:r>
             <a:endParaRPr lang="en-US" sz="950" dirty="0"/>
           </a:p>
@@ -18380,13 +18268,13 @@
       </p:sp>
       <p:sp>
         <p:nvSpPr>
-          <p:cNvPr id="36" name="Text 34"/>
-          <p:cNvSpPr/>
-          <p:nvPr/>
-        </p:nvSpPr>
-        <p:spPr>
-          <a:xfrm>
-            <a:off x="6172200" y="3913632"/>
+          <p:cNvPr id="38" name="Text 36"/>
+          <p:cNvSpPr/>
+          <p:nvPr/>
+        </p:nvSpPr>
+        <p:spPr>
+          <a:xfrm>
+            <a:off x="6162260" y="3254469"/>
             <a:ext cx="5577840" cy="228600"/>
           </a:xfrm>
           <a:prstGeom prst="rect">
@@ -18399,78 +18287,19 @@
           <a:bodyPr wrap="square" lIns="0" tIns="0" rIns="0" bIns="0" rtlCol="0" anchor="ctr"/>
           <a:lstStyle/>
           <a:p>
-            <a:pPr marL="0" indent="0">
-              <a:buNone/>
-            </a:pPr>
-            <a:endParaRPr lang="en-US" sz="950" dirty="0"/>
-          </a:p>
-        </p:txBody>
-      </p:sp>
-      <p:sp>
-        <p:nvSpPr>
-          <p:cNvPr id="37" name="Text 35"/>
-          <p:cNvSpPr/>
-          <p:nvPr/>
-        </p:nvSpPr>
-        <p:spPr>
-          <a:xfrm>
-            <a:off x="6172200" y="4160520"/>
-            <a:ext cx="5577840" cy="228600"/>
-          </a:xfrm>
-          <a:prstGeom prst="rect">
-            <a:avLst/>
-          </a:prstGeom>
-          <a:noFill/>
-          <a:ln/>
-        </p:spPr>
-        <p:txBody>
-          <a:bodyPr wrap="square" lIns="0" tIns="0" rIns="0" bIns="0" rtlCol="0" anchor="ctr"/>
-          <a:lstStyle/>
-          <a:p>
-            <a:pPr marL="0" indent="0">
-              <a:buNone/>
-            </a:pPr>
             <a:r>
               <a:rPr lang="en-US" sz="950" dirty="0">
                 <a:solidFill>
-                  <a:srgbClr val="F59E0B"/>
+                  <a:srgbClr val="E6EDF3"/>
                 </a:solidFill>
                 <a:latin typeface="Consolas" pitchFamily="34" charset="0"/>
                 <a:ea typeface="Consolas" pitchFamily="34" charset="-122"/>
                 <a:cs typeface="Consolas" pitchFamily="34" charset="-120"/>
               </a:rPr>
-              <a:t>MODEL = 'gemini-2.5-flash-lite'</a:t>
-            </a:r>
-            <a:endParaRPr lang="en-US" sz="950" dirty="0"/>
-          </a:p>
-        </p:txBody>
-      </p:sp>
-      <p:sp>
-        <p:nvSpPr>
-          <p:cNvPr id="38" name="Text 36"/>
-          <p:cNvSpPr/>
-          <p:nvPr/>
-        </p:nvSpPr>
-        <p:spPr>
-          <a:xfrm>
-            <a:off x="6172200" y="4407408"/>
-            <a:ext cx="5577840" cy="228600"/>
-          </a:xfrm>
-          <a:prstGeom prst="rect">
-            <a:avLst/>
-          </a:prstGeom>
-          <a:noFill/>
-          <a:ln/>
-        </p:spPr>
-        <p:txBody>
-          <a:bodyPr wrap="square" lIns="0" tIns="0" rIns="0" bIns="0" rtlCol="0" anchor="ctr"/>
-          <a:lstStyle/>
-          <a:p>
-            <a:pPr marL="0" indent="0">
-              <a:buNone/>
-            </a:pPr>
-            <a:r>
-              <a:rPr lang="en-US" sz="950" dirty="0">
+              <a:t>client = </a:t>
+            </a:r>
+            <a:r>
+              <a:rPr lang="en-US" sz="950" dirty="0" err="1">
                 <a:solidFill>
                   <a:srgbClr val="E6EDF3"/>
                 </a:solidFill>
@@ -18478,105 +18307,21 @@
                 <a:ea typeface="Consolas" pitchFamily="34" charset="-122"/>
                 <a:cs typeface="Consolas" pitchFamily="34" charset="-120"/>
               </a:rPr>
-              <a:t>client = genai.Client()</a:t>
-            </a:r>
-            <a:endParaRPr lang="en-US" sz="950" dirty="0"/>
-          </a:p>
-        </p:txBody>
-      </p:sp>
-      <p:sp>
-        <p:nvSpPr>
-          <p:cNvPr id="39" name="Text 37"/>
-          <p:cNvSpPr/>
-          <p:nvPr/>
-        </p:nvSpPr>
-        <p:spPr>
-          <a:xfrm>
-            <a:off x="6172200" y="4654296"/>
-            <a:ext cx="5577840" cy="228600"/>
-          </a:xfrm>
-          <a:prstGeom prst="rect">
-            <a:avLst/>
-          </a:prstGeom>
-          <a:noFill/>
-          <a:ln/>
-        </p:spPr>
-        <p:txBody>
-          <a:bodyPr wrap="square" lIns="0" tIns="0" rIns="0" bIns="0" rtlCol="0" anchor="ctr"/>
-          <a:lstStyle/>
-          <a:p>
-            <a:pPr marL="0" indent="0">
-              <a:buNone/>
-            </a:pPr>
-            <a:endParaRPr lang="en-US" sz="950" dirty="0"/>
-          </a:p>
-        </p:txBody>
-      </p:sp>
-      <p:sp>
-        <p:nvSpPr>
-          <p:cNvPr id="40" name="Text 38"/>
-          <p:cNvSpPr/>
-          <p:nvPr/>
-        </p:nvSpPr>
-        <p:spPr>
-          <a:xfrm>
-            <a:off x="6172200" y="4901184"/>
-            <a:ext cx="5577840" cy="228600"/>
-          </a:xfrm>
-          <a:prstGeom prst="rect">
-            <a:avLst/>
-          </a:prstGeom>
-          <a:noFill/>
-          <a:ln/>
-        </p:spPr>
-        <p:txBody>
-          <a:bodyPr wrap="square" lIns="0" tIns="0" rIns="0" bIns="0" rtlCol="0" anchor="ctr"/>
-          <a:lstStyle/>
-          <a:p>
-            <a:pPr marL="0" indent="0">
-              <a:buNone/>
-            </a:pPr>
+              <a:t>genai.Client</a:t>
+            </a:r>
             <a:r>
               <a:rPr lang="en-US" sz="950" dirty="0">
                 <a:solidFill>
-                  <a:srgbClr val="8B949E"/>
+                  <a:srgbClr val="E6EDF3"/>
                 </a:solidFill>
                 <a:latin typeface="Consolas" pitchFamily="34" charset="0"/>
                 <a:ea typeface="Consolas" pitchFamily="34" charset="-122"/>
                 <a:cs typeface="Consolas" pitchFamily="34" charset="-120"/>
               </a:rPr>
-              <a:t># Cell 4: ask() 헬퍼 함수</a:t>
-            </a:r>
-            <a:endParaRPr lang="en-US" sz="950" dirty="0"/>
-          </a:p>
-        </p:txBody>
-      </p:sp>
-      <p:sp>
-        <p:nvSpPr>
-          <p:cNvPr id="41" name="Text 39"/>
-          <p:cNvSpPr/>
-          <p:nvPr/>
-        </p:nvSpPr>
-        <p:spPr>
-          <a:xfrm>
-            <a:off x="6172200" y="5148072"/>
-            <a:ext cx="5577840" cy="228600"/>
-          </a:xfrm>
-          <a:prstGeom prst="rect">
-            <a:avLst/>
-          </a:prstGeom>
-          <a:noFill/>
-          <a:ln/>
-        </p:spPr>
-        <p:txBody>
-          <a:bodyPr wrap="square" lIns="0" tIns="0" rIns="0" bIns="0" rtlCol="0" anchor="ctr"/>
-          <a:lstStyle/>
-          <a:p>
-            <a:pPr marL="0" indent="0">
-              <a:buNone/>
-            </a:pPr>
-            <a:r>
-              <a:rPr lang="en-US" sz="950" dirty="0">
+              <a:t>(</a:t>
+            </a:r>
+            <a:r>
+              <a:rPr lang="en-US" sz="950" dirty="0" err="1">
                 <a:solidFill>
                   <a:srgbClr val="E6EDF3"/>
                 </a:solidFill>
@@ -18584,36 +18329,8 @@
                 <a:ea typeface="Consolas" pitchFamily="34" charset="-122"/>
                 <a:cs typeface="Consolas" pitchFamily="34" charset="-120"/>
               </a:rPr>
-              <a:t>def ask(prompt, system=None):</a:t>
-            </a:r>
-            <a:endParaRPr lang="en-US" sz="950" dirty="0"/>
-          </a:p>
-        </p:txBody>
-      </p:sp>
-      <p:sp>
-        <p:nvSpPr>
-          <p:cNvPr id="42" name="Text 40"/>
-          <p:cNvSpPr/>
-          <p:nvPr/>
-        </p:nvSpPr>
-        <p:spPr>
-          <a:xfrm>
-            <a:off x="6172200" y="5394960"/>
-            <a:ext cx="5577840" cy="228600"/>
-          </a:xfrm>
-          <a:prstGeom prst="rect">
-            <a:avLst/>
-          </a:prstGeom>
-          <a:noFill/>
-          <a:ln/>
-        </p:spPr>
-        <p:txBody>
-          <a:bodyPr wrap="square" lIns="0" tIns="0" rIns="0" bIns="0" rtlCol="0" anchor="ctr"/>
-          <a:lstStyle/>
-          <a:p>
-            <a:pPr marL="0" indent="0">
-              <a:buNone/>
-            </a:pPr>
+              <a:t>api_key</a:t>
+            </a:r>
             <a:r>
               <a:rPr lang="en-US" sz="950" dirty="0">
                 <a:solidFill>
@@ -18623,7 +18340,7 @@
                 <a:ea typeface="Consolas" pitchFamily="34" charset="-122"/>
                 <a:cs typeface="Consolas" pitchFamily="34" charset="-120"/>
               </a:rPr>
-              <a:t>  from google.genai import types</a:t>
+              <a:t>=GEMINI_API_KEY)</a:t>
             </a:r>
             <a:endParaRPr lang="en-US" sz="950" dirty="0"/>
           </a:p>
@@ -18631,13 +18348,13 @@
       </p:sp>
       <p:sp>
         <p:nvSpPr>
-          <p:cNvPr id="43" name="Text 41"/>
-          <p:cNvSpPr/>
-          <p:nvPr/>
-        </p:nvSpPr>
-        <p:spPr>
-          <a:xfrm>
-            <a:off x="6172200" y="5641848"/>
+          <p:cNvPr id="39" name="Text 37"/>
+          <p:cNvSpPr/>
+          <p:nvPr/>
+        </p:nvSpPr>
+        <p:spPr>
+          <a:xfrm>
+            <a:off x="6172200" y="4654296"/>
             <a:ext cx="5577840" cy="228600"/>
           </a:xfrm>
           <a:prstGeom prst="rect">
@@ -18653,16 +18370,44 @@
             <a:pPr marL="0" indent="0">
               <a:buNone/>
             </a:pPr>
+            <a:endParaRPr lang="en-US" sz="950" dirty="0"/>
+          </a:p>
+        </p:txBody>
+      </p:sp>
+      <p:sp>
+        <p:nvSpPr>
+          <p:cNvPr id="40" name="Text 38"/>
+          <p:cNvSpPr/>
+          <p:nvPr/>
+        </p:nvSpPr>
+        <p:spPr>
+          <a:xfrm>
+            <a:off x="6172200" y="3569342"/>
+            <a:ext cx="5577840" cy="228600"/>
+          </a:xfrm>
+          <a:prstGeom prst="rect">
+            <a:avLst/>
+          </a:prstGeom>
+          <a:noFill/>
+          <a:ln/>
+        </p:spPr>
+        <p:txBody>
+          <a:bodyPr wrap="square" lIns="0" tIns="0" rIns="0" bIns="0" rtlCol="0" anchor="ctr"/>
+          <a:lstStyle/>
+          <a:p>
+            <a:pPr marL="0" indent="0">
+              <a:buNone/>
+            </a:pPr>
             <a:r>
               <a:rPr lang="en-US" sz="950" dirty="0">
                 <a:solidFill>
-                  <a:srgbClr val="E6EDF3"/>
+                  <a:srgbClr val="8B949E"/>
                 </a:solidFill>
                 <a:latin typeface="Consolas" pitchFamily="34" charset="0"/>
                 <a:ea typeface="Consolas" pitchFamily="34" charset="-122"/>
                 <a:cs typeface="Consolas" pitchFamily="34" charset="-120"/>
               </a:rPr>
-              <a:t>  config = types.GenerateContentConfig(</a:t>
+              <a:t># Cell 4: ask() 헬퍼 함수</a:t>
             </a:r>
             <a:endParaRPr lang="en-US" sz="950" dirty="0"/>
           </a:p>
@@ -18670,13 +18415,13 @@
       </p:sp>
       <p:sp>
         <p:nvSpPr>
-          <p:cNvPr id="44" name="Text 42"/>
-          <p:cNvSpPr/>
-          <p:nvPr/>
-        </p:nvSpPr>
-        <p:spPr>
-          <a:xfrm>
-            <a:off x="6172200" y="5888736"/>
+          <p:cNvPr id="41" name="Text 39"/>
+          <p:cNvSpPr/>
+          <p:nvPr/>
+        </p:nvSpPr>
+        <p:spPr>
+          <a:xfrm>
+            <a:off x="6172200" y="3816230"/>
             <a:ext cx="5577840" cy="228600"/>
           </a:xfrm>
           <a:prstGeom prst="rect">
@@ -18701,7 +18446,7 @@
                 <a:ea typeface="Consolas" pitchFamily="34" charset="-122"/>
                 <a:cs typeface="Consolas" pitchFamily="34" charset="-120"/>
               </a:rPr>
-              <a:t>    system_instruction=system) if system else None</a:t>
+              <a:t>def ask(prompt, system=None):</a:t>
             </a:r>
             <a:endParaRPr lang="en-US" sz="950" dirty="0"/>
           </a:p>
@@ -18709,13 +18454,13 @@
       </p:sp>
       <p:sp>
         <p:nvSpPr>
-          <p:cNvPr id="45" name="Text 43"/>
-          <p:cNvSpPr/>
-          <p:nvPr/>
-        </p:nvSpPr>
-        <p:spPr>
-          <a:xfrm>
-            <a:off x="6172200" y="6135624"/>
+          <p:cNvPr id="42" name="Text 40"/>
+          <p:cNvSpPr/>
+          <p:nvPr/>
+        </p:nvSpPr>
+        <p:spPr>
+          <a:xfrm>
+            <a:off x="6172200" y="4063118"/>
             <a:ext cx="5577840" cy="228600"/>
           </a:xfrm>
           <a:prstGeom prst="rect">
@@ -18740,6 +18485,123 @@
                 <a:ea typeface="Consolas" pitchFamily="34" charset="-122"/>
                 <a:cs typeface="Consolas" pitchFamily="34" charset="-120"/>
               </a:rPr>
+              <a:t>  from google.genai import types</a:t>
+            </a:r>
+            <a:endParaRPr lang="en-US" sz="950" dirty="0"/>
+          </a:p>
+        </p:txBody>
+      </p:sp>
+      <p:sp>
+        <p:nvSpPr>
+          <p:cNvPr id="43" name="Text 41"/>
+          <p:cNvSpPr/>
+          <p:nvPr/>
+        </p:nvSpPr>
+        <p:spPr>
+          <a:xfrm>
+            <a:off x="6172200" y="4310006"/>
+            <a:ext cx="5577840" cy="228600"/>
+          </a:xfrm>
+          <a:prstGeom prst="rect">
+            <a:avLst/>
+          </a:prstGeom>
+          <a:noFill/>
+          <a:ln/>
+        </p:spPr>
+        <p:txBody>
+          <a:bodyPr wrap="square" lIns="0" tIns="0" rIns="0" bIns="0" rtlCol="0" anchor="ctr"/>
+          <a:lstStyle/>
+          <a:p>
+            <a:pPr marL="0" indent="0">
+              <a:buNone/>
+            </a:pPr>
+            <a:r>
+              <a:rPr lang="en-US" sz="950" dirty="0">
+                <a:solidFill>
+                  <a:srgbClr val="E6EDF3"/>
+                </a:solidFill>
+                <a:latin typeface="Consolas" pitchFamily="34" charset="0"/>
+                <a:ea typeface="Consolas" pitchFamily="34" charset="-122"/>
+                <a:cs typeface="Consolas" pitchFamily="34" charset="-120"/>
+              </a:rPr>
+              <a:t>  config = types.GenerateContentConfig(</a:t>
+            </a:r>
+            <a:endParaRPr lang="en-US" sz="950" dirty="0"/>
+          </a:p>
+        </p:txBody>
+      </p:sp>
+      <p:sp>
+        <p:nvSpPr>
+          <p:cNvPr id="44" name="Text 42"/>
+          <p:cNvSpPr/>
+          <p:nvPr/>
+        </p:nvSpPr>
+        <p:spPr>
+          <a:xfrm>
+            <a:off x="6172200" y="4556894"/>
+            <a:ext cx="5577840" cy="228600"/>
+          </a:xfrm>
+          <a:prstGeom prst="rect">
+            <a:avLst/>
+          </a:prstGeom>
+          <a:noFill/>
+          <a:ln/>
+        </p:spPr>
+        <p:txBody>
+          <a:bodyPr wrap="square" lIns="0" tIns="0" rIns="0" bIns="0" rtlCol="0" anchor="ctr"/>
+          <a:lstStyle/>
+          <a:p>
+            <a:pPr marL="0" indent="0">
+              <a:buNone/>
+            </a:pPr>
+            <a:r>
+              <a:rPr lang="en-US" sz="950" dirty="0">
+                <a:solidFill>
+                  <a:srgbClr val="E6EDF3"/>
+                </a:solidFill>
+                <a:latin typeface="Consolas" pitchFamily="34" charset="0"/>
+                <a:ea typeface="Consolas" pitchFamily="34" charset="-122"/>
+                <a:cs typeface="Consolas" pitchFamily="34" charset="-120"/>
+              </a:rPr>
+              <a:t>    system_instruction=system) if system else None</a:t>
+            </a:r>
+            <a:endParaRPr lang="en-US" sz="950" dirty="0"/>
+          </a:p>
+        </p:txBody>
+      </p:sp>
+      <p:sp>
+        <p:nvSpPr>
+          <p:cNvPr id="45" name="Text 43"/>
+          <p:cNvSpPr/>
+          <p:nvPr/>
+        </p:nvSpPr>
+        <p:spPr>
+          <a:xfrm>
+            <a:off x="6172200" y="4803782"/>
+            <a:ext cx="5577840" cy="228600"/>
+          </a:xfrm>
+          <a:prstGeom prst="rect">
+            <a:avLst/>
+          </a:prstGeom>
+          <a:noFill/>
+          <a:ln/>
+        </p:spPr>
+        <p:txBody>
+          <a:bodyPr wrap="square" lIns="0" tIns="0" rIns="0" bIns="0" rtlCol="0" anchor="ctr"/>
+          <a:lstStyle/>
+          <a:p>
+            <a:pPr marL="0" indent="0">
+              <a:buNone/>
+            </a:pPr>
+            <a:r>
+              <a:rPr lang="en-US" sz="950" dirty="0">
+                <a:solidFill>
+                  <a:srgbClr val="E6EDF3"/>
+                </a:solidFill>
+                <a:latin typeface="Consolas" pitchFamily="34" charset="0"/>
+                <a:ea typeface="Consolas" pitchFamily="34" charset="-122"/>
+                <a:cs typeface="Consolas" pitchFamily="34" charset="-120"/>
+              </a:rPr>
               <a:t>  return client.models.generate_content(</a:t>
             </a:r>
             <a:endParaRPr lang="en-US" sz="950" dirty="0"/>
@@ -18754,7 +18616,7 @@
         </p:nvSpPr>
         <p:spPr>
           <a:xfrm>
-            <a:off x="6172200" y="6382512"/>
+            <a:off x="6172200" y="5050670"/>
             <a:ext cx="5577840" cy="228600"/>
           </a:xfrm>
           <a:prstGeom prst="rect">

</xml_diff>